<commit_message>
feat: public uploads, optional verification, Pro plan display and motion
- Uploads are public as soon as they're shared; moderator approval is gone.
- Authors can request free verification of a version; the verifier works a
  Verification queue (requested, reported, all public) and marks versions
  verified. Reports still hide a pack until it is restored.
- Pro plan (priority verification, more storage, bookmark folders) is shown
  in an upgrade dialog from five entry points; it is display-only.
- State schema 4 migrates older saved pending packs to public.
- Scroll/fade reveals, homepage intro, card hover/press and page fade with
  reduced-motion variants; UI polish pass on shared primitives.
- Also includes pending work: profiles, revisions, settings, sign-in,
  version history, new fictional samples and logo.
- README rewritten with requirements, setup and a walkthrough; DEMO, PLAN
  and PROJECT_MEMORY updated.

Co-Authored-By: Claude Opus 5.5 <noreply@anthropic.com>
</commit_message>
<xml_diff>
--- a/sample-packs/Ma'am Cora/Grade 6 - English - Writing a persuasive notice for a clean barangay/Slides.pptx
+++ b/sample-packs/Ma'am Cora/Grade 6 - English - Writing a persuasive notice for a clean barangay/Slides.pptx
@@ -151,16 +151,6 @@
                 </a:solidFill>
               </a:rPr>
               <a:t>Learners write a short persuasive notice that asks neighbours to segregate waste, using reasons and a call to action.</a:t>
-            </a:r>
-          </a:p>
-          <a:p>
-            <a:r>
-              <a:rPr lang="en-US" sz="2400">
-                <a:solidFill>
-                  <a:srgbClr val="332C27"/>
-                </a:solidFill>
-              </a:rPr>
-              <a:t>Fictional placeholder made by the CherIt team for a hackathon demonstration.</a:t>
             </a:r>
           </a:p>
         </p:txBody>

</xml_diff>